<commit_message>
v1.1.0 - Overtime, touchdown tries, 4th & 1 precision, This week tab, sharing
Overtime is valued by team strength now that both teams get the ball; after a
touchdown the scorer takes the better of the extra point and the 2-point try;
4th & 1 can be "inches" or "a full yard" (Lopez 2020) and the grader corrects
for it. New: a weekly page of the costliest and best calls (scheduled GitHub
Action every Tuesday), an edge calibration check, a matchup picker, a one-line
"why", share links, install-to-home-screen and coach habits.

Co-Authored-By: Claude Opus 5.5 <noreply@anthropic.com>
</commit_message>
<xml_diff>
--- a/docs/fourth-down-deck.pptx
+++ b/docs/fourth-down-deck.pptx
@@ -3171,7 +3171,7 @@
             </a:pPr>
             <a:r>
               <a:rPr sz="2200"/>
-              <a:t>• Version 1.0.0</a:t>
+              <a:t>• Version 1.1.0</a:t>
             </a:r>
           </a:p>
         </p:txBody>
@@ -4145,7 +4145,7 @@
             </a:pPr>
             <a:r>
               <a:rPr sz="2200"/>
-              <a:t>• Furthest from it: Todd Bowles, Shane Steichen, Sean Payton</a:t>
+              <a:t>• Furthest from it: Shane Steichen, Todd Bowles, Sean Payton</a:t>
             </a:r>
           </a:p>
           <a:p>

</xml_diff>

<commit_message>
v1.2.0 - Grade past seasons under their own kickoff rule; live game mode
Every post-score kickoff used the 2025 starting spot, so older seasons gave the
opponent 5-8 free yards after each score, undervaluing kicks and judging
long-tenured coaches more harshly. Each graded decision now uses its season's
measured spot. Adds "Fill from a live game" (ESPN public scoreboard, app/live.js)
with fixture tests, and a game-day slide in the deck.

Co-Authored-By: Claude Opus 5.5 <noreply@anthropic.com>
</commit_message>
<xml_diff>
--- a/docs/fourth-down-deck.pptx
+++ b/docs/fourth-down-deck.pptx
@@ -16,6 +16,7 @@
     <p:sldId id="264" r:id="rId15"/>
     <p:sldId id="265" r:id="rId16"/>
     <p:sldId id="266" r:id="rId17"/>
+    <p:sldId id="267" r:id="rId18"/>
   </p:sldIdLst>
   <p:sldSz cx="12191695" cy="6858000" type="screen4x3"/>
   <p:notesSz cx="6858000" cy="9144000"/>
@@ -3171,7 +3172,7 @@
             </a:pPr>
             <a:r>
               <a:rPr sz="2200"/>
-              <a:t>• Version 1.1.0</a:t>
+              <a:t>• Version 1.2.0</a:t>
             </a:r>
           </a:p>
         </p:txBody>
@@ -3222,7 +3223,7 @@
                   <a:srgbClr val="1F5130"/>
                 </a:solidFill>
               </a:rPr>
-              <a:t>What it can't tell you</a:t>
+              <a:t>Built for game day</a:t>
             </a:r>
           </a:p>
         </p:txBody>
@@ -3256,7 +3257,7 @@
             </a:pPr>
             <a:r>
               <a:rPr sz="2200"/>
-              <a:t>• '4th and 1' can mean inches or a full yard; the data can't tell them apart</a:t>
+              <a:t>• Fill from a live game: pick the game and your side, and the score, clock, down and spot fill in</a:t>
             </a:r>
           </a:p>
           <a:p>
@@ -3267,7 +3268,7 @@
             </a:pPr>
             <a:r>
               <a:rPr sz="2200"/>
-              <a:t>• It can't prove that following it wins more games: no one has run that experiment</a:t>
+              <a:t>• Pick the two teams and the stadium, roof and your kicker are set for you</a:t>
             </a:r>
           </a:p>
           <a:p>
@@ -3278,7 +3279,29 @@
             </a:pPr>
             <a:r>
               <a:rPr sz="2200"/>
-              <a:t>• Small edges are toss-ups, not mistakes</a:t>
+              <a:t>• Share any call as a link that opens straight to the answer</a:t>
+            </a:r>
+          </a:p>
+          <a:p>
+            <a:pPr>
+              <a:spcAft>
+                <a:spcPts val="1000"/>
+              </a:spcAft>
+            </a:pPr>
+            <a:r>
+              <a:rPr sz="2200"/>
+              <a:t>• Every Tuesday: the week's costliest calls and best gutsy ones</a:t>
+            </a:r>
+          </a:p>
+          <a:p>
+            <a:pPr>
+              <a:spcAft>
+                <a:spcPts val="1000"/>
+              </a:spcAft>
+            </a:pPr>
+            <a:r>
+              <a:rPr sz="2200"/>
+              <a:t>• willhoop.github.io/fourth-down — add it to your phone's home screen</a:t>
             </a:r>
           </a:p>
         </p:txBody>
@@ -3329,6 +3352,113 @@
                   <a:srgbClr val="1F5130"/>
                 </a:solidFill>
               </a:rPr>
+              <a:t>What it can't tell you</a:t>
+            </a:r>
+          </a:p>
+        </p:txBody>
+      </p:sp>
+      <p:sp>
+        <p:nvSpPr>
+          <p:cNvPr id="3" name="TextBox 2"/>
+          <p:cNvSpPr txBox="1"/>
+          <p:nvPr/>
+        </p:nvSpPr>
+        <p:spPr>
+          <a:xfrm>
+            <a:off x="914400" y="2011680"/>
+            <a:ext cx="10332720" cy="4389120"/>
+          </a:xfrm>
+          <a:prstGeom prst="rect">
+            <a:avLst/>
+          </a:prstGeom>
+          <a:noFill/>
+        </p:spPr>
+        <p:txBody>
+          <a:bodyPr wrap="square">
+            <a:spAutoFit/>
+          </a:bodyPr>
+          <a:lstStyle/>
+          <a:p>
+            <a:pPr>
+              <a:spcAft>
+                <a:spcPts val="1000"/>
+              </a:spcAft>
+            </a:pPr>
+            <a:r>
+              <a:rPr sz="2200"/>
+              <a:t>• '4th and 1' can mean inches or a full yard; the data can't tell them apart</a:t>
+            </a:r>
+          </a:p>
+          <a:p>
+            <a:pPr>
+              <a:spcAft>
+                <a:spcPts val="1000"/>
+              </a:spcAft>
+            </a:pPr>
+            <a:r>
+              <a:rPr sz="2200"/>
+              <a:t>• It can't prove that following it wins more games: no one has run that experiment</a:t>
+            </a:r>
+          </a:p>
+          <a:p>
+            <a:pPr>
+              <a:spcAft>
+                <a:spcPts val="1000"/>
+              </a:spcAft>
+            </a:pPr>
+            <a:r>
+              <a:rPr sz="2200"/>
+              <a:t>• Small edges are toss-ups, not mistakes</a:t>
+            </a:r>
+          </a:p>
+        </p:txBody>
+      </p:sp>
+    </p:spTree>
+  </p:cSld>
+  <p:clrMapOvr>
+    <a:masterClrMapping/>
+  </p:clrMapOvr>
+</p:sld>
+</file>
+
+<file path=ppt/slides/slide12.xml><?xml version="1.0" encoding="utf-8"?>
+<p:sld xmlns:a="http://schemas.openxmlformats.org/drawingml/2006/main" xmlns:p="http://schemas.openxmlformats.org/presentationml/2006/main" xmlns:r="http://schemas.openxmlformats.org/officeDocument/2006/relationships">
+  <p:cSld>
+    <p:spTree>
+      <p:nvGrpSpPr>
+        <p:cNvPr id="1" name=""/>
+        <p:cNvGrpSpPr/>
+        <p:nvPr/>
+      </p:nvGrpSpPr>
+      <p:grpSpPr/>
+      <p:sp>
+        <p:nvSpPr>
+          <p:cNvPr id="2" name="TextBox 1"/>
+          <p:cNvSpPr txBox="1"/>
+          <p:nvPr/>
+        </p:nvSpPr>
+        <p:spPr>
+          <a:xfrm>
+            <a:off x="914400" y="731520"/>
+            <a:ext cx="10332720" cy="1097280"/>
+          </a:xfrm>
+          <a:prstGeom prst="rect">
+            <a:avLst/>
+          </a:prstGeom>
+          <a:noFill/>
+        </p:spPr>
+        <p:txBody>
+          <a:bodyPr wrap="square">
+            <a:spAutoFit/>
+          </a:bodyPr>
+          <a:lstStyle/>
+          <a:p>
+            <a:r>
+              <a:rPr sz="4000" b="1">
+                <a:solidFill>
+                  <a:srgbClr val="1F5130"/>
+                </a:solidFill>
+              </a:rPr>
               <a:t>Read the full story</a:t>
             </a:r>
           </a:p>
@@ -4134,7 +4264,7 @@
             </a:pPr>
             <a:r>
               <a:rPr sz="2200"/>
-              <a:t>• Closest to the math: Liam Coen, Mike Macdonald, Dan Campbell</a:t>
+              <a:t>• Closest to the math: Liam Coen, Sean McDermott, Matt LaFleur</a:t>
             </a:r>
           </a:p>
           <a:p>

</xml_diff>